<commit_message>
Slides: sd-06-013 slide 6 centres on the lesson's 20.000, re-export PPTX
Co-Authored-By: Claude Opus 5.5 <noreply@anthropic.com>
Claude-Session: https://claude.ai/code/session_01C9pH8NnezrynRr5dznPeP3
</commit_message>
<xml_diff>
--- a/system-design-101/vi/lessons/sd-06-013/slides/sd-06-013.pptx
+++ b/system-design-101/vi/lessons/sd-06-013/slides/sd-06-013.pptx
@@ -8954,7 +8954,7 @@
               <a:buNone/>
             </a:pPr>
             <a:r>
-              <a:rPr lang="en-US" sz="13500" dirty="0" spc="0" kern="0">
+              <a:rPr lang="en-US" sz="13500" dirty="0" spc="-92" kern="0">
                 <a:solidFill>
                   <a:srgbClr val="FF6A4D"/>
                 </a:solidFill>
@@ -8962,18 +8962,7 @@
                 <a:ea typeface="Bricolage Grotesque ExtraBold" pitchFamily="34" charset="-122"/>
                 <a:cs typeface="Bricolage Grotesque ExtraBold" pitchFamily="34" charset="-120"/>
               </a:rPr>
-              <a:t>mỗi</a:t>
-            </a:r>
-            <a:r>
-              <a:rPr lang="en-US" sz="13500" dirty="0" spc="2" kern="0">
-                <a:solidFill>
-                  <a:srgbClr val="FF6A4D"/>
-                </a:solidFill>
-                <a:latin typeface="Bricolage Grotesque ExtraBold" pitchFamily="34" charset="0"/>
-                <a:ea typeface="Bricolage Grotesque ExtraBold" pitchFamily="34" charset="-122"/>
-                <a:cs typeface="Bricolage Grotesque ExtraBold" pitchFamily="34" charset="-120"/>
-              </a:rPr>
-              <a:t> mã</a:t>
+              <a:t>20.000</a:t>
             </a:r>
             <a:endParaRPr lang="en-US" sz="13500" dirty="0"/>
           </a:p>
@@ -9007,6 +8996,17 @@
               <a:buNone/>
             </a:pPr>
             <a:r>
+              <a:rPr lang="en-US" sz="2550" dirty="0" spc="2" kern="0">
+                <a:solidFill>
+                  <a:srgbClr val="E4E1D8"/>
+                </a:solidFill>
+                <a:latin typeface="Be Vietnam Pro" pitchFamily="34" charset="0"/>
+                <a:ea typeface="Be Vietnam Pro" pitchFamily="34" charset="-122"/>
+                <a:cs typeface="Be Vietnam Pro" pitchFamily="34" charset="-120"/>
+              </a:rPr>
+              <a:t>mã</a:t>
+            </a:r>
+            <a:r>
               <a:rPr lang="en-US" sz="2550" dirty="0" spc="1" kern="0">
                 <a:solidFill>
                   <a:srgbClr val="E4E1D8"/>
@@ -9015,7 +9015,40 @@
                 <a:ea typeface="Be Vietnam Pro" pitchFamily="34" charset="-122"/>
                 <a:cs typeface="Be Vietnam Pro" pitchFamily="34" charset="-120"/>
               </a:rPr>
-              <a:t>chỉ</a:t>
+              <a:t> khác</a:t>
+            </a:r>
+            <a:r>
+              <a:rPr lang="en-US" sz="2550" dirty="0" spc="0" kern="0">
+                <a:solidFill>
+                  <a:srgbClr val="E4E1D8"/>
+                </a:solidFill>
+                <a:latin typeface="Be Vietnam Pro" pitchFamily="34" charset="0"/>
+                <a:ea typeface="Be Vietnam Pro" pitchFamily="34" charset="-122"/>
+                <a:cs typeface="Be Vietnam Pro" pitchFamily="34" charset="-120"/>
+              </a:rPr>
+              <a:t> nhau</a:t>
+            </a:r>
+            <a:r>
+              <a:rPr lang="en-US" sz="2550" dirty="0" spc="-14" kern="0">
+                <a:solidFill>
+                  <a:srgbClr val="E4E1D8"/>
+                </a:solidFill>
+                <a:latin typeface="Be Vietnam Pro" pitchFamily="34" charset="0"/>
+                <a:ea typeface="Be Vietnam Pro" pitchFamily="34" charset="-122"/>
+                <a:cs typeface="Be Vietnam Pro" pitchFamily="34" charset="-120"/>
+              </a:rPr>
+              <a:t> vẫn</a:t>
+            </a:r>
+            <a:r>
+              <a:rPr lang="en-US" sz="2550" dirty="0" spc="1" kern="0">
+                <a:solidFill>
+                  <a:srgbClr val="E4E1D8"/>
+                </a:solidFill>
+                <a:latin typeface="Be Vietnam Pro" pitchFamily="34" charset="0"/>
+                <a:ea typeface="Be Vietnam Pro" pitchFamily="34" charset="-122"/>
+                <a:cs typeface="Be Vietnam Pro" pitchFamily="34" charset="-120"/>
+              </a:rPr>
+              <a:t> là</a:t>
             </a:r>
             <a:r>
               <a:rPr lang="en-US" sz="2550" dirty="0" spc="-1" kern="0">
@@ -9026,10 +9059,10 @@
                 <a:ea typeface="Be Vietnam Pro" pitchFamily="34" charset="-122"/>
                 <a:cs typeface="Be Vietnam Pro" pitchFamily="34" charset="-120"/>
               </a:rPr>
-              <a:t> hỏi</a:t>
-            </a:r>
-            <a:r>
-              <a:rPr lang="en-US" sz="2550" dirty="0" spc="-5" kern="0">
+              <a:t> 20.000</a:t>
+            </a:r>
+            <a:r>
+              <a:rPr lang="en-US" sz="2550" dirty="0" spc="1" kern="0">
                 <a:solidFill>
                   <a:srgbClr val="E4E1D8"/>
                 </a:solidFill>
@@ -9037,10 +9070,10 @@
                 <a:ea typeface="Be Vietnam Pro" pitchFamily="34" charset="-122"/>
                 <a:cs typeface="Be Vietnam Pro" pitchFamily="34" charset="-120"/>
               </a:rPr>
-              <a:t> một</a:t>
-            </a:r>
-            <a:r>
-              <a:rPr lang="en-US" sz="2550" dirty="0" spc="1" kern="0">
+              <a:t> lần</a:t>
+            </a:r>
+            <a:r>
+              <a:rPr lang="en-US" sz="2550" dirty="0" spc="0" kern="0">
                 <a:solidFill>
                   <a:srgbClr val="E4E1D8"/>
                 </a:solidFill>
@@ -9048,62 +9081,7 @@
                 <a:ea typeface="Be Vietnam Pro" pitchFamily="34" charset="-122"/>
                 <a:cs typeface="Be Vietnam Pro" pitchFamily="34" charset="-120"/>
               </a:rPr>
-              <a:t> lần: giá</a:t>
-            </a:r>
-            <a:r>
-              <a:rPr lang="en-US" sz="2550" dirty="0" spc="14" kern="0">
-                <a:solidFill>
-                  <a:srgbClr val="E4E1D8"/>
-                </a:solidFill>
-                <a:latin typeface="Be Vietnam Pro" pitchFamily="34" charset="0"/>
-                <a:ea typeface="Be Vietnam Pro" pitchFamily="34" charset="-122"/>
-                <a:cs typeface="Be Vietnam Pro" pitchFamily="34" charset="-120"/>
-              </a:rPr>
-              <a:t> trị</a:t>
-            </a:r>
-            <a:r>
-              <a:rPr lang="en-US" sz="2550" dirty="0" spc="-21" kern="0">
-                <a:solidFill>
-                  <a:srgbClr val="E4E1D8"/>
-                </a:solidFill>
-                <a:latin typeface="Be Vietnam Pro" pitchFamily="34" charset="0"/>
-                <a:ea typeface="Be Vietnam Pro" pitchFamily="34" charset="-122"/>
-                <a:cs typeface="Be Vietnam Pro" pitchFamily="34" charset="-120"/>
-              </a:rPr>
-              <a:t> rỗng</a:t>
-            </a:r>
-            <a:r>
-              <a:rPr lang="en-US" sz="2550" dirty="0" spc="1" kern="0">
-                <a:solidFill>
-                  <a:srgbClr val="E4E1D8"/>
-                </a:solidFill>
-                <a:latin typeface="Be Vietnam Pro" pitchFamily="34" charset="0"/>
-                <a:ea typeface="Be Vietnam Pro" pitchFamily="34" charset="-122"/>
-                <a:cs typeface="Be Vietnam Pro" pitchFamily="34" charset="-120"/>
-              </a:rPr>
-              <a:t> không</a:t>
-            </a:r>
-            <a:r>
-              <a:rPr lang="en-US" sz="2550" dirty="0" spc="-1" kern="0">
-                <a:solidFill>
-                  <a:srgbClr val="E4E1D8"/>
-                </a:solidFill>
-                <a:latin typeface="Be Vietnam Pro" pitchFamily="34" charset="0"/>
-                <a:ea typeface="Be Vietnam Pro" pitchFamily="34" charset="-122"/>
-                <a:cs typeface="Be Vietnam Pro" pitchFamily="34" charset="-120"/>
-              </a:rPr>
-              <a:t> dùng</a:t>
-            </a:r>
-            <a:r>
-              <a:rPr lang="en-US" sz="2550" dirty="0" spc="0" kern="0">
-                <a:solidFill>
-                  <a:srgbClr val="E4E1D8"/>
-                </a:solidFill>
-                <a:latin typeface="Be Vietnam Pro" pitchFamily="34" charset="0"/>
-                <a:ea typeface="Be Vietnam Pro" pitchFamily="34" charset="-122"/>
-                <a:cs typeface="Be Vietnam Pro" pitchFamily="34" charset="-120"/>
-              </a:rPr>
-              <a:t> lại.</a:t>
+              <a:t> hỏi.</a:t>
             </a:r>
             <a:endParaRPr lang="en-US" sz="2550" dirty="0"/>
           </a:p>

</xml_diff>